<commit_message>
chore: Update website and recompile documents with compliance report and A4 diagrams
</commit_message>
<xml_diff>
--- a/collateral/pitch-deck.pptx
+++ b/collateral/pitch-deck.pptx
@@ -7275,7 +7275,7 @@
               </a:defRPr>
             </a:pPr>
             <a:r>
-              <a:t>MALKHANA VAULT: GOVERNMENT-READY</a:t>
+              <a:t>MALKHANA VAULT: SECURE &amp; DEPLOYABLE</a:t>
             </a:r>
           </a:p>
           <a:p>
@@ -7291,7 +7291,7 @@
               </a:defRPr>
             </a:pPr>
             <a:r>
-              <a:t>Open core model designed for grassroot adoption and seamless district scale.</a:t>
+              <a:t>Standardized packages designed for grassroots police deployment and air-gapped security.</a:t>
             </a:r>
           </a:p>
         </p:txBody>
@@ -7330,7 +7330,7 @@
                 </a:solidFill>
                 <a:latin typeface="Calibri"/>
               </a:rPr>
-              <a:t>■  Tier 0: Open Core (Free): </a:t>
+              <a:t>■  AppImage (Tauri Portable): </a:t>
             </a:r>
             <a:r>
               <a:rPr sz="1500">
@@ -7339,7 +7339,7 @@
                 </a:solidFill>
                 <a:latin typeface="Calibri"/>
               </a:rPr>
-              <a:t>Individual IOs and small rural stations. Air-gapped single-user AppImage.</a:t>
+              <a:t>Runs instantly on Linux workstations without installation or administrator privileges.</a:t>
             </a:r>
           </a:p>
           <a:p>
@@ -7355,7 +7355,7 @@
                 </a:solidFill>
                 <a:latin typeface="Calibri"/>
               </a:rPr>
-              <a:t>■  Tier 1: Station License (₹15,000/yr): </a:t>
+              <a:t>■  Debian / RPM Installers: </a:t>
             </a:r>
             <a:r>
               <a:rPr sz="1500">
@@ -7364,7 +7364,7 @@
                 </a:solidFill>
                 <a:latin typeface="Calibri"/>
               </a:rPr>
-              <a:t>Individual police stations. 5 seats, local installers, email support.</a:t>
+              <a:t>Native packages for official state Linux distributions (Ubuntu, BOSS Linux).</a:t>
             </a:r>
           </a:p>
           <a:p>
@@ -7380,7 +7380,7 @@
                 </a:solidFill>
                 <a:latin typeface="Calibri"/>
               </a:rPr>
-              <a:t>■  Tier 2: District License (₹75,000/yr): </a:t>
+              <a:t>■  Windows MSIs (NSIS): </a:t>
             </a:r>
             <a:r>
               <a:rPr sz="1500">
@@ -7389,7 +7389,7 @@
                 </a:solidFill>
                 <a:latin typeface="Calibri"/>
               </a:rPr>
-              <a:t>SP Office and District HQ. 25 seats, metadata sync, dashboard.</a:t>
+              <a:t>Standard installers with automatic dependency resolution for Windows terminals.</a:t>
             </a:r>
           </a:p>
           <a:p>
@@ -7405,7 +7405,7 @@
                 </a:solidFill>
                 <a:latin typeface="Calibri"/>
               </a:rPr>
-              <a:t>■  Tier 3: State/Central License (Custom): </a:t>
+              <a:t>■  100% Offline Integrity: </a:t>
             </a:r>
             <a:r>
               <a:rPr sz="1500">
@@ -7414,7 +7414,7 @@
                 </a:solidFill>
                 <a:latin typeface="Calibri"/>
               </a:rPr>
-              <a:t>State Cyber Cells, CBI, NIA. On-prem servers, customized SLA.</a:t>
+              <a:t>Statically compiled SQLite/SQLCipher database. Zero external web calls or data leaks.</a:t>
             </a:r>
           </a:p>
         </p:txBody>

</xml_diff>